<commit_message>
feat(deck): pitch refreshed — real live-site screenshot, running-Qwen story on every slide, Findex-sourced stats
</commit_message>
<xml_diff>
--- a/presentation/Bizro_Pitch.pptx
+++ b/presentation/Bizro_Pitch.pptx
@@ -1072,7 +1072,7 @@
           <a:lstStyle/>
           <a:p>
             <a:r>
-              <a:t>The backbone is deliberately provider-agnostic. Voice goes to speech-to-text, then to structured JSON with confidence scores, then to an Urdu narrative for loan officers. Today it runs entirely on free tiers; switching to Qwen through Alibaba Cloud Model Studio — the production path — is literally one environment variable.</a:t>
+              <a:t>The backbone is deliberately provider-agnostic. Voice goes to Qwen ASR, then to structured JSON with confidence scores, then to a lender-ready narrative. It runs on Qwen through Alibaba Cloud Model Studio today — speech, vision and parsing — verified live in production, with a Groq Whisper backup for speech. Swapping any model is literally one environment variable.</a:t>
             </a:r>
           </a:p>
         </p:txBody>
@@ -5106,7 +5106,46 @@
       </p:sp>
       <p:sp>
         <p:nvSpPr>
-          <p:cNvPr id="9" name="Rectangle 8"/>
+          <p:cNvPr id="9" name="TextBox 8"/>
+          <p:cNvSpPr txBox="1"/>
+          <p:nvPr/>
+        </p:nvSpPr>
+        <p:spPr>
+          <a:xfrm>
+            <a:off x="868680" y="3651504"/>
+            <a:ext cx="10424160" cy="320040"/>
+          </a:xfrm>
+          <a:prstGeom prst="rect">
+            <a:avLst/>
+          </a:prstGeom>
+          <a:noFill/>
+        </p:spPr>
+        <p:txBody>
+          <a:bodyPr wrap="square" anchor="t" lIns="45720" rIns="45720" tIns="18288" bIns="18288">
+            <a:spAutoFit/>
+          </a:bodyPr>
+          <a:lstStyle/>
+          <a:p>
+            <a:pPr algn="l">
+              <a:lnSpc>
+                <a:spcPct val="100000"/>
+              </a:lnSpc>
+            </a:pPr>
+            <a:r>
+              <a:rPr sz="1100" b="0">
+                <a:solidFill>
+                  <a:srgbClr val="F5F1E6"/>
+                </a:solidFill>
+                <a:latin typeface="Arial"/>
+              </a:rPr>
+              <a:t>Scale estimate: informal micro-enterprises vs the 10.3% formal-account share (World Bank Global Findex).</a:t>
+            </a:r>
+          </a:p>
+        </p:txBody>
+      </p:sp>
+      <p:sp>
+        <p:nvSpPr>
+          <p:cNvPr id="10" name="Rectangle 9"/>
           <p:cNvSpPr/>
           <p:nvPr/>
         </p:nvSpPr>
@@ -5150,7 +5189,7 @@
       </p:sp>
       <p:sp>
         <p:nvSpPr>
-          <p:cNvPr id="10" name="Rectangle 9"/>
+          <p:cNvPr id="11" name="Rectangle 10"/>
           <p:cNvSpPr/>
           <p:nvPr/>
         </p:nvSpPr>
@@ -5196,7 +5235,7 @@
       </p:sp>
       <p:sp>
         <p:nvSpPr>
-          <p:cNvPr id="11" name="TextBox 10"/>
+          <p:cNvPr id="12" name="TextBox 11"/>
           <p:cNvSpPr txBox="1"/>
           <p:nvPr/>
         </p:nvSpPr>
@@ -5235,7 +5274,7 @@
       </p:sp>
       <p:sp>
         <p:nvSpPr>
-          <p:cNvPr id="12" name="Rectangle 11"/>
+          <p:cNvPr id="13" name="Rectangle 12"/>
           <p:cNvSpPr/>
           <p:nvPr/>
         </p:nvSpPr>
@@ -5279,7 +5318,7 @@
       </p:sp>
       <p:sp>
         <p:nvSpPr>
-          <p:cNvPr id="13" name="Rectangle 12"/>
+          <p:cNvPr id="14" name="Rectangle 13"/>
           <p:cNvSpPr/>
           <p:nvPr/>
         </p:nvSpPr>
@@ -5325,7 +5364,7 @@
       </p:sp>
       <p:sp>
         <p:nvSpPr>
-          <p:cNvPr id="14" name="TextBox 13"/>
+          <p:cNvPr id="15" name="TextBox 14"/>
           <p:cNvSpPr txBox="1"/>
           <p:nvPr/>
         </p:nvSpPr>
@@ -5364,7 +5403,7 @@
       </p:sp>
       <p:sp>
         <p:nvSpPr>
-          <p:cNvPr id="15" name="Rectangle 14"/>
+          <p:cNvPr id="16" name="Rectangle 15"/>
           <p:cNvSpPr/>
           <p:nvPr/>
         </p:nvSpPr>
@@ -5408,7 +5447,7 @@
       </p:sp>
       <p:sp>
         <p:nvSpPr>
-          <p:cNvPr id="16" name="Rectangle 15"/>
+          <p:cNvPr id="17" name="Rectangle 16"/>
           <p:cNvSpPr/>
           <p:nvPr/>
         </p:nvSpPr>
@@ -5454,7 +5493,7 @@
       </p:sp>
       <p:sp>
         <p:nvSpPr>
-          <p:cNvPr id="17" name="TextBox 16"/>
+          <p:cNvPr id="18" name="TextBox 17"/>
           <p:cNvSpPr txBox="1"/>
           <p:nvPr/>
         </p:nvSpPr>
@@ -5493,7 +5532,7 @@
       </p:sp>
       <p:sp>
         <p:nvSpPr>
-          <p:cNvPr id="18" name="TextBox 17"/>
+          <p:cNvPr id="19" name="TextBox 18"/>
           <p:cNvSpPr txBox="1"/>
           <p:nvPr/>
         </p:nvSpPr>
@@ -6532,7 +6571,7 @@
                 </a:solidFill>
                 <a:latin typeface="Arial"/>
               </a:rPr>
-              <a:t>of Pakistani adults hold a formal financial-institution account — at the last national baseline.</a:t>
+              <a:t>of Pakistani adults hold a formal financial-institution account — World Bank Global Findex.</a:t>
             </a:r>
           </a:p>
         </p:txBody>
@@ -6755,7 +6794,7 @@
                 </a:solidFill>
                 <a:latin typeface="Arial"/>
               </a:rPr>
-              <a:t>the South Asian average of adults with a formal financial-institution account.</a:t>
+              <a:t>the South Asian average of adults with a formal financial-institution account (World Bank Global Findex).</a:t>
             </a:r>
           </a:p>
         </p:txBody>
@@ -8751,7 +8790,7 @@
                 </a:solidFill>
                 <a:latin typeface="Arial"/>
               </a:rPr>
-              <a:t>Qwen3.5-Omni-Plus</a:t>
+              <a:t>Qwen ASR + Qwen Flash</a:t>
             </a:r>
           </a:p>
         </p:txBody>
@@ -9353,7 +9392,7 @@
                 </a:solidFill>
                 <a:latin typeface="Arial"/>
               </a:rPr>
-              <a:t>Qwen3.7-Plus</a:t>
+              <a:t>Qwen Flash</a:t>
             </a:r>
           </a:p>
         </p:txBody>
@@ -9873,45 +9912,30 @@
           </a:p>
         </p:txBody>
       </p:sp>
-      <p:sp>
-        <p:nvSpPr>
-          <p:cNvPr id="12" name="TextBox 11"/>
-          <p:cNvSpPr txBox="1"/>
-          <p:nvPr/>
-        </p:nvSpPr>
-        <p:spPr>
-          <a:xfrm>
-            <a:off x="7680960" y="2701036"/>
-            <a:ext cx="3749039" cy="640080"/>
-          </a:xfrm>
-          <a:prstGeom prst="rect">
-            <a:avLst/>
-          </a:prstGeom>
-          <a:noFill/>
-        </p:spPr>
-        <p:txBody>
-          <a:bodyPr wrap="square" anchor="t" lIns="45720" rIns="45720" tIns="18288" bIns="18288">
-            <a:spAutoFit/>
-          </a:bodyPr>
-          <a:lstStyle/>
-          <a:p>
-            <a:pPr algn="ctr">
-              <a:lnSpc>
-                <a:spcPct val="100000"/>
-              </a:lnSpc>
-            </a:pPr>
-            <a:r>
-              <a:rPr sz="1400" b="1">
-                <a:solidFill>
-                  <a:srgbClr val="1F7A6C"/>
-                </a:solidFill>
-                <a:latin typeface="Arial"/>
-              </a:rPr>
-              <a:t>[ screenshot space ]</a:t>
-            </a:r>
-          </a:p>
-        </p:txBody>
-      </p:sp>
+      <p:pic>
+        <p:nvPicPr>
+          <p:cNvPr id="12" name="Picture 11" descr="demo-live.png"/>
+          <p:cNvPicPr>
+            <a:picLocks noChangeAspect="1"/>
+          </p:cNvPicPr>
+          <p:nvPr/>
+        </p:nvPicPr>
+        <p:blipFill>
+          <a:blip r:embed="rId2"/>
+          <a:stretch>
+            <a:fillRect/>
+          </a:stretch>
+        </p:blipFill>
+        <p:spPr>
+          <a:xfrm>
+            <a:off x="7607808" y="1942084"/>
+            <a:ext cx="3895344" cy="1803625"/>
+          </a:xfrm>
+          <a:prstGeom prst="rect">
+            <a:avLst/>
+          </a:prstGeom>
+        </p:spPr>
+      </p:pic>
       <p:sp>
         <p:nvSpPr>
           <p:cNvPr id="13" name="Rectangle 12"/>
@@ -10617,7 +10641,7 @@
                 </a:solidFill>
                 <a:latin typeface="Arial"/>
               </a:rPr>
-              <a:t>Qwen3.5-Omni-Plus · WhatsApp in / out</a:t>
+              <a:t>Qwen ASR + Qwen Flash · WhatsApp in / out</a:t>
             </a:r>
           </a:p>
         </p:txBody>
@@ -11233,7 +11257,7 @@
                 </a:solidFill>
                 <a:latin typeface="Arial"/>
               </a:rPr>
-              <a:t>Qwen3.7-Plus · Mawakhat-style format</a:t>
+              <a:t>Qwen Flash · Mawakhat-style format</a:t>
             </a:r>
           </a:p>
         </p:txBody>
@@ -11688,7 +11712,7 @@
                 </a:solidFill>
                 <a:latin typeface="Arial"/>
               </a:rPr>
-              <a:t>Urdu / mixed-language voice note → transcript. Runs on Qwen3.5-Omni-Plus.</a:t>
+              <a:t>Urdu / mixed-language voice note → transcript. Runs on Qwen ASR (qwen3-asr-flash).</a:t>
             </a:r>
           </a:p>
         </p:txBody>
@@ -12194,7 +12218,7 @@
                 </a:solidFill>
                 <a:latin typeface="Arial"/>
               </a:rPr>
-              <a:t>Ledger history → a Credit Readiness Report a loan officer can read, reasoned by Qwen3.7-Plus.</a:t>
+              <a:t>Ledger history → a Credit Readiness Report a loan officer can read, reasoned by Qwen Flash.</a:t>
             </a:r>
           </a:p>
         </p:txBody>
@@ -12319,11 +12343,11 @@
             <a:r>
               <a:rPr sz="1800" b="1">
                 <a:solidFill>
-                  <a:srgbClr val="F5F1E6"/>
+                  <a:srgbClr val="E9A93D"/>
                 </a:solidFill>
-                <a:latin typeface="Arial"/>
+                <a:latin typeface="Arial Black"/>
               </a:rPr>
-              <a:t>Runs on free tiers today. </a:t>
+              <a:t>Running end-to-end on Qwen today </a:t>
             </a:r>
             <a:r>
               <a:rPr sz="1800" b="0">
@@ -12332,16 +12356,16 @@
                 </a:solidFill>
                 <a:latin typeface="Arial"/>
               </a:rPr>
-              <a:t>Qwen via Alibaba Cloud Model Studio is the production path — </a:t>
+              <a:t>— speech, vision and parsing on Alibaba Cloud Model Studio, with a Groq Whisper backup. </a:t>
             </a:r>
             <a:r>
               <a:rPr sz="1800" b="1">
                 <a:solidFill>
                   <a:srgbClr val="F5F1E6"/>
                 </a:solidFill>
-                <a:latin typeface="Arial Black"/>
+                <a:latin typeface="Arial"/>
               </a:rPr>
-              <a:t>one environment variable.</a:t>
+              <a:t>Provider-agnostic: one environment variable.</a:t>
             </a:r>
           </a:p>
         </p:txBody>
@@ -12380,7 +12404,7 @@
                 </a:solidFill>
                 <a:latin typeface="Arial"/>
               </a:rPr>
-              <a:t>Stack: FastAPI + Postgres-compatible storage · React dashboard · WhatsApp Cloud API shape · deployed on Vercel.</a:t>
+              <a:t>Stack: Qwen (qwen3-asr-flash · qwen-flash · qwen-vl-ocr) · FastAPI + Neon Postgres · React dashboard · WhatsApp Cloud API, signatures enforced · Vercel.</a:t>
             </a:r>
           </a:p>
         </p:txBody>
@@ -13439,7 +13463,7 @@
                 </a:solidFill>
                 <a:latin typeface="Arial"/>
               </a:rPr>
-              <a:t>Parsed by Qwen3.5-Omni-Plus · confidence 96%</a:t>
+              <a:t>Parsed by Qwen Flash · confidence 96%</a:t>
             </a:r>
           </a:p>
         </p:txBody>

</xml_diff>

<commit_message>
fix(deck): slide-5 screenshot is now the actual record-a-note demo card
Judge round-2 residual: the previous capture showed the hero illustration,
not the mic demo. Re-captured with Chrome MCP, DOM-verified both the green
'Tap to record a note' pill and the invoice card in-viewport, cropped to the
demo-frame (529x533), and fit the near-square asset by height centered in
the panel. Verified on the rendered slide: green pill pixels within the
picture bounds (9.31-11.55 x 2.12-4.38 in), inside the panel frame.
</commit_message>
<xml_diff>
--- a/presentation/Bizro_Pitch.pptx
+++ b/presentation/Bizro_Pitch.pptx
@@ -9928,8 +9928,8 @@
         </p:blipFill>
         <p:spPr>
           <a:xfrm>
-            <a:off x="7607808" y="1942084"/>
-            <a:ext cx="3895344" cy="1803625"/>
+            <a:off x="8514394" y="1942084"/>
+            <a:ext cx="2051034" cy="2066543"/>
           </a:xfrm>
           <a:prstGeom prst="rect">
             <a:avLst/>

</xml_diff>